<commit_message>
Randomization v2: reshape 'common hypotheses' into one pattern + table
Replace the dry four-case catalog (12 stacked display equations) with a
unifying paragraph (null = no-effect value; alt = a chosen direction) and a
compact reference table anchored to the chapter's own examples (cereal,
coin, video, income). Fold one/two-sided in right after. Heading -> 'The
shape of a hypothesis'.

Co-Authored-By: Claude Opus 4.8 <noreply@anthropic.com>
Claude-Session: https://claude.ai/code/session_01ApPPVtS7Gk1xQdKrjLJbBy
</commit_message>
<xml_diff>
--- a/STAT145/resources-2027/randomization/slides.pptx
+++ b/STAT145/resources-2027/randomization/slides.pptx
@@ -11246,79 +11246,7 @@
 </p:sld>
 </file>
 
-<file path=ppt/slides/slide7.xml><?xml version="1.0" encoding="utf-8"?>
-<p:sld xmlns:a="http://schemas.openxmlformats.org/drawingml/2006/main" xmlns:r="http://schemas.openxmlformats.org/officeDocument/2006/relationships" xmlns:p="http://schemas.openxmlformats.org/presentationml/2006/main">
-  <p:cSld>
-    <p:spTree>
-      <p:nvGrpSpPr>
-        <p:cNvPr id="1" name=""/>
-        <p:cNvGrpSpPr/>
-        <p:nvPr/>
-      </p:nvGrpSpPr>
-      <p:grpSpPr>
-        <a:xfrm>
-          <a:off x="0" y="0"/>
-          <a:ext cx="0" cy="0"/>
-          <a:chOff x="0" y="0"/>
-          <a:chExt cx="0" cy="0"/>
-        </a:xfrm>
-      </p:grpSpPr>
-      <p:sp>
-        <p:nvSpPr>
-          <p:cNvPr id="2" name="Title 1"/>
-          <p:cNvSpPr>
-            <a:spLocks noGrp="1"/>
-          </p:cNvSpPr>
-          <p:nvPr>
-            <p:ph type="title"/>
-          </p:nvPr>
-        </p:nvSpPr>
-        <p:spPr/>
-        <p:txBody>
-          <a:bodyPr/>
-          <a:lstStyle/>
-          <a:p>
-            <a:pPr lvl="0" indent="0" marL="0">
-              <a:buNone/>
-            </a:pPr>
-            <a:r>
-              <a:rPr/>
-              <a:t>Null and alternative hypotheses</a:t>
-            </a:r>
-          </a:p>
-        </p:txBody>
-      </p:sp>
-      <p:sp>
-        <p:nvSpPr>
-          <p:cNvPr id="3" name="Content Placeholder 2"/>
-          <p:cNvSpPr>
-            <a:spLocks noGrp="1"/>
-          </p:cNvSpPr>
-          <p:nvPr>
-            <p:ph idx="1"/>
-          </p:nvPr>
-        </p:nvSpPr>
-        <p:spPr/>
-        <p:txBody>
-          <a:bodyPr/>
-          <a:lstStyle/>
-          <a:p>
-            <a:pPr lvl="0" indent="0" marL="0">
-              <a:spcBef>
-                <a:spcPts val="3000"/>
-              </a:spcBef>
-              <a:buNone/>
-            </a:pPr>
-            <a:r>
-              <a:rPr b="1"/>
-              <a:t>Sets of common hypotheses</a:t>
-            </a:r>
-          </a:p>
-        </p:txBody>
-      </p:sp>
-    </p:spTree>
-  </p:cSld>
-</p:sld>
+<file path=ppt/slides/slide7.xml><?xml version="1.0" encoding="UTF-8"?><p:sld xmlns:a="http://schemas.openxmlformats.org/drawingml/2006/main" xmlns:r="http://schemas.openxmlformats.org/officeDocument/2006/relationships" xmlns:p="http://schemas.openxmlformats.org/presentationml/2006/main"><p:cSld><p:spTree><p:nvGrpSpPr><p:cNvPr id="1" name="" /><p:cNvGrpSpPr /><p:nvPr /></p:nvGrpSpPr><p:grpSpPr><a:xfrm><a:off x="0" y="0" /><a:ext cx="0" cy="0" /><a:chOff x="0" y="0" /><a:chExt cx="0" cy="0" /></a:xfrm></p:grpSpPr><p:sp><p:nvSpPr><p:cNvPr id="2" name="Title 1" /><p:cNvSpPr><a:spLocks noGrp="1" /></p:cNvSpPr><p:nvPr><p:ph type="title" /></p:nvPr></p:nvSpPr><p:spPr><a:xfrm><a:off x="457201" y="204787" /><a:ext cx="3008313" cy="871538" /></a:xfrm></p:spPr><p:txBody><a:bodyPr /><a:lstStyle /><a:p><a:pPr lvl="0" indent="0" marL="0"><a:buNone /></a:pPr><a:r><a:rPr /><a:t>Null and alternative hypotheses</a:t></a:r></a:p></p:txBody></p:sp><p:sp><p:nvSpPr><p:cNvPr id="4" name="Text Placeholder 3" /><p:cNvSpPr><a:spLocks noGrp="1" /></p:cNvSpPr><p:nvPr><p:ph idx="2" sz="half" type="body" /></p:nvPr></p:nvSpPr><p:spPr /><p:txBody><a:bodyPr /><a:lstStyle /><a:p><a:pPr lvl="0" indent="0" marL="0"><a:spcBef><a:spcPts val="3000" /></a:spcBef><a:buNone /></a:pPr><a:r><a:rPr b="1" /><a:t>The shape of a hypothesis</a:t></a:r></a:p></p:txBody></p:sp><p:graphicFrame><p:nvGraphicFramePr><p:cNvPr id="6" name="Content Placeholder 5" /><p:cNvGraphicFramePr><a:graphicFrameLocks noGrp="1" /></p:cNvGraphicFramePr><p:nvPr><p:ph idx="1" /></p:nvPr></p:nvGraphicFramePr><p:xfrm><a:off x="3568700" y="203200" /><a:ext cx="5105400" cy="4381500" /></p:xfrm><a:graphic><a:graphicData uri="http://schemas.openxmlformats.org/drawingml/2006/table"><a:tbl><a:tblPr firstRow="1" bandRow="1"><a:tableStyleId>{5C22544A-7EE6-4342-B048-85BDC9FD1C3A}</a:tableStyleId></a:tblPr><a:tblGrid><a:gridCol w="1130300" /><a:gridCol w="1422400" /><a:gridCol w="1422400" /><a:gridCol w="1130300" /></a:tblGrid><a:tr h="0"><a:tc><a:txBody><a:bodyPr /><a:lstStyle /><a:p><a:pPr lvl="0" indent="0" marL="0" algn="l"><a:buNone /></a:pPr><a:r><a:rPr /><a:t>The question is about…</a:t></a:r></a:p></a:txBody><a:tcPr /></a:tc><a:tc><a:txBody><a:bodyPr /><a:lstStyle /><a:p><a:pPr lvl="0" indent="0" marL="0" algn="ctr"><a:buNone /></a:pPr><a:r><a:rPr /><a:t>Null hypothesis (“no effect”)</a:t></a:r></a:p></a:txBody><a:tcPr /></a:tc><a:tc><a:txBody><a:bodyPr /><a:lstStyle /><a:p><a:pPr lvl="0" indent="0" marL="0" algn="ctr"><a:buNone /></a:pPr><a:r><a:rPr /><a:t>Alternative (pick one direction)</a:t></a:r></a:p></a:txBody><a:tcPr /></a:tc><a:tc><a:txBody><a:bodyPr /><a:lstStyle /><a:p><a:pPr lvl="0" indent="0" marL="0" algn="l"><a:buNone /></a:pPr><a:r><a:rPr /><a:t>A question of this kind</a:t></a:r></a:p></a:txBody><a:tcPr /></a:tc></a:tr><a:tr h="0"><a:tc><a:txBody><a:bodyPr /><a:lstStyle /><a:p><a:pPr lvl="0" indent="0" marL="0" algn="l"><a:buNone /></a:pPr><a:r><a:rPr /><a:t>one proportion </a:t></a:r><a14:m><m:oMath xmlns:m="http://schemas.openxmlformats.org/officeDocument/2006/math"><m:r><m:t>p</m:t></m:r></m:oMath></a14:m></a:p></a:txBody></a:tc><a:tc><a:txBody><a:bodyPr /><a:lstStyle /><a:p><a:pPr lvl="0" indent="0" marL="0" algn="ctr"><a:buNone /></a:pPr><a14:m><m:oMath xmlns:m="http://schemas.openxmlformats.org/officeDocument/2006/math"><m:r><m:t>p</m:t></m:r><m:r><m:rPr><m:sty m:val="p" /></m:rPr><m:t>=</m:t></m:r><m:sSub><m:e><m:r><m:t>p</m:t></m:r></m:e><m:sub><m:r><m:t>0</m:t></m:r></m:sub></m:sSub></m:oMath></a14:m></a:p></a:txBody></a:tc><a:tc><a:txBody><a:bodyPr /><a:lstStyle /><a:p><a:pPr lvl="0" indent="0" marL="0" algn="ctr"><a:buNone /></a:pPr><a14:m><m:oMath xmlns:m="http://schemas.openxmlformats.org/officeDocument/2006/math"><m:r><m:t>p</m:t></m:r><m:r><m:rPr><m:sty m:val="p" /></m:rPr><m:t>≠</m:t></m:r><m:sSub><m:e><m:r><m:t>p</m:t></m:r></m:e><m:sub><m:r><m:t>0</m:t></m:r></m:sub></m:sSub><m:r><m:rPr><m:sty m:val="p" /></m:rPr><m:t>,</m:t></m:r><m:r><m:t> </m:t></m:r><m:r><m:t>p</m:t></m:r><m:r><m:rPr><m:sty m:val="p" /></m:rPr><m:t>&gt;</m:t></m:r><m:sSub><m:e><m:r><m:t>p</m:t></m:r></m:e><m:sub><m:r><m:t>0</m:t></m:r></m:sub></m:sSub><m:r><m:rPr><m:sty m:val="p" /></m:rPr><m:t>,</m:t></m:r><m:r><m:t> </m:t></m:r><m:r><m:t>p</m:t></m:r><m:r><m:rPr><m:sty m:val="p" /></m:rPr><m:t>&lt;</m:t></m:r><m:sSub><m:e><m:r><m:t>p</m:t></m:r></m:e><m:sub><m:r><m:t>0</m:t></m:r></m:sub></m:sSub></m:oMath></a14:m></a:p></a:txBody></a:tc><a:tc><a:txBody><a:bodyPr /><a:lstStyle /><a:p><a:pPr lvl="0" indent="0" marL="0" algn="l"><a:buNone /></a:pPr><a:r><a:rPr /><a:t>Do more than half of children pick the cartoon box? (</a:t></a:r><a14:m><m:oMath xmlns:m="http://schemas.openxmlformats.org/officeDocument/2006/math"><m:sSub><m:e><m:r><m:t>p</m:t></m:r></m:e><m:sub><m:r><m:t>0</m:t></m:r></m:sub></m:sSub><m:r><m:rPr><m:sty m:val="p" /></m:rPr><m:t>=</m:t></m:r><m:r><m:t>0.5</m:t></m:r></m:oMath></a14:m><a:r><a:rPr /><a:t>)</a:t></a:r></a:p></a:txBody></a:tc></a:tr><a:tr h="0"><a:tc><a:txBody><a:bodyPr /><a:lstStyle /><a:p><a:pPr lvl="0" indent="0" marL="0" algn="l"><a:buNone /></a:pPr><a:r><a:rPr /><a:t>one mean </a:t></a:r><a14:m><m:oMath xmlns:m="http://schemas.openxmlformats.org/officeDocument/2006/math"><m:r><m:t>μ</m:t></m:r></m:oMath></a14:m></a:p></a:txBody></a:tc><a:tc><a:txBody><a:bodyPr /><a:lstStyle /><a:p><a:pPr lvl="0" indent="0" marL="0" algn="ctr"><a:buNone /></a:pPr><a14:m><m:oMath xmlns:m="http://schemas.openxmlformats.org/officeDocument/2006/math"><m:r><m:t>μ</m:t></m:r><m:r><m:rPr><m:sty m:val="p" /></m:rPr><m:t>=</m:t></m:r><m:sSub><m:e><m:r><m:t>μ</m:t></m:r></m:e><m:sub><m:r><m:t>0</m:t></m:r></m:sub></m:sSub></m:oMath></a14:m></a:p></a:txBody></a:tc><a:tc><a:txBody><a:bodyPr /><a:lstStyle /><a:p><a:pPr lvl="0" indent="0" marL="0" algn="ctr"><a:buNone /></a:pPr><a14:m><m:oMath xmlns:m="http://schemas.openxmlformats.org/officeDocument/2006/math"><m:r><m:t>μ</m:t></m:r><m:r><m:rPr><m:sty m:val="p" /></m:rPr><m:t>≠</m:t></m:r><m:sSub><m:e><m:r><m:t>μ</m:t></m:r></m:e><m:sub><m:r><m:t>0</m:t></m:r></m:sub></m:sSub><m:r><m:rPr><m:sty m:val="p" /></m:rPr><m:t>,</m:t></m:r><m:r><m:t> </m:t></m:r><m:r><m:t>μ</m:t></m:r><m:r><m:rPr><m:sty m:val="p" /></m:rPr><m:t>&gt;</m:t></m:r><m:sSub><m:e><m:r><m:t>μ</m:t></m:r></m:e><m:sub><m:r><m:t>0</m:t></m:r></m:sub></m:sSub><m:r><m:rPr><m:sty m:val="p" /></m:rPr><m:t>,</m:t></m:r><m:r><m:t> </m:t></m:r><m:r><m:t>μ</m:t></m:r><m:r><m:rPr><m:sty m:val="p" /></m:rPr><m:t>&lt;</m:t></m:r><m:sSub><m:e><m:r><m:t>μ</m:t></m:r></m:e><m:sub><m:r><m:t>0</m:t></m:r></m:sub></m:sSub></m:oMath></a14:m></a:p></a:txBody></a:tc><a:tc><a:txBody><a:bodyPr /><a:lstStyle /><a:p><a:pPr lvl="0" indent="0" marL="0" algn="l"><a:buNone /></a:pPr><a:r><a:rPr /><a:t>Do the bags really average the 16 oz on the label? (</a:t></a:r><a14:m><m:oMath xmlns:m="http://schemas.openxmlformats.org/officeDocument/2006/math"><m:sSub><m:e><m:r><m:t>μ</m:t></m:r></m:e><m:sub><m:r><m:t>0</m:t></m:r></m:sub></m:sSub><m:r><m:rPr><m:sty m:val="p" /></m:rPr><m:t>=</m:t></m:r><m:r><m:t>16</m:t></m:r></m:oMath></a14:m><a:r><a:rPr /><a:t>)</a:t></a:r></a:p></a:txBody></a:tc></a:tr><a:tr h="0"><a:tc><a:txBody><a:bodyPr /><a:lstStyle /><a:p><a:pPr lvl="0" indent="0" marL="0" algn="l"><a:buNone /></a:pPr><a:r><a:rPr /><a:t>a difference in proportions</a:t></a:r></a:p></a:txBody></a:tc><a:tc><a:txBody><a:bodyPr /><a:lstStyle /><a:p><a:pPr lvl="0" indent="0" marL="0" algn="ctr"><a:buNone /></a:pPr><a14:m><m:oMath xmlns:m="http://schemas.openxmlformats.org/officeDocument/2006/math"><m:sSub><m:e><m:r><m:t>p</m:t></m:r></m:e><m:sub><m:r><m:t>1</m:t></m:r></m:sub></m:sSub><m:r><m:rPr><m:sty m:val="p" /></m:rPr><m:t>−</m:t></m:r><m:sSub><m:e><m:r><m:t>p</m:t></m:r></m:e><m:sub><m:r><m:t>2</m:t></m:r></m:sub></m:sSub><m:r><m:rPr><m:sty m:val="p" /></m:rPr><m:t>=</m:t></m:r><m:r><m:t>0</m:t></m:r></m:oMath></a14:m></a:p></a:txBody></a:tc><a:tc><a:txBody><a:bodyPr /><a:lstStyle /><a:p><a:pPr lvl="0" indent="0" marL="0" algn="ctr"><a:buNone /></a:pPr><a14:m><m:oMath xmlns:m="http://schemas.openxmlformats.org/officeDocument/2006/math"><m:sSub><m:e><m:r><m:t>p</m:t></m:r></m:e><m:sub><m:r><m:t>1</m:t></m:r></m:sub></m:sSub><m:r><m:rPr><m:sty m:val="p" /></m:rPr><m:t>−</m:t></m:r><m:sSub><m:e><m:r><m:t>p</m:t></m:r></m:e><m:sub><m:r><m:t>2</m:t></m:r></m:sub></m:sSub><m:r><m:rPr><m:sty m:val="p" /></m:rPr><m:t>≠</m:t></m:r><m:r><m:t>0</m:t></m:r><m:r><m:rPr><m:sty m:val="p" /></m:rPr><m:t>,</m:t></m:r><m:r><m:t> </m:t></m:r><m:r><m:rPr><m:sty m:val="p" /></m:rPr><m:t>&gt;</m:t></m:r><m:r><m:t>0</m:t></m:r><m:r><m:rPr><m:sty m:val="p" /></m:rPr><m:t>,</m:t></m:r><m:r><m:t> </m:t></m:r><m:r><m:rPr><m:sty m:val="p" /></m:rPr><m:t>&lt;</m:t></m:r><m:r><m:t>0</m:t></m:r></m:oMath></a14:m></a:p></a:txBody></a:tc><a:tc><a:txBody><a:bodyPr /><a:lstStyle /><a:p><a:pPr lvl="0" indent="0" marL="0" algn="l"><a:buNone /></a:pPr><a:r><a:rPr /><a:t>Do two groups differ in who skips the video?</a:t></a:r></a:p></a:txBody></a:tc></a:tr><a:tr h="0"><a:tc><a:txBody><a:bodyPr /><a:lstStyle /><a:p><a:pPr lvl="0" indent="0" marL="0" algn="l"><a:buNone /></a:pPr><a:r><a:rPr /><a:t>a difference in means</a:t></a:r></a:p></a:txBody></a:tc><a:tc><a:txBody><a:bodyPr /><a:lstStyle /><a:p><a:pPr lvl="0" indent="0" marL="0" algn="ctr"><a:buNone /></a:pPr><a14:m><m:oMath xmlns:m="http://schemas.openxmlformats.org/officeDocument/2006/math"><m:sSub><m:e><m:r><m:t>μ</m:t></m:r></m:e><m:sub><m:r><m:t>1</m:t></m:r></m:sub></m:sSub><m:r><m:rPr><m:sty m:val="p" /></m:rPr><m:t>−</m:t></m:r><m:sSub><m:e><m:r><m:t>μ</m:t></m:r></m:e><m:sub><m:r><m:t>2</m:t></m:r></m:sub></m:sSub><m:r><m:rPr><m:sty m:val="p" /></m:rPr><m:t>=</m:t></m:r><m:r><m:t>0</m:t></m:r></m:oMath></a14:m></a:p></a:txBody></a:tc><a:tc><a:txBody><a:bodyPr /><a:lstStyle /><a:p><a:pPr lvl="0" indent="0" marL="0" algn="ctr"><a:buNone /></a:pPr><a14:m><m:oMath xmlns:m="http://schemas.openxmlformats.org/officeDocument/2006/math"><m:sSub><m:e><m:r><m:t>μ</m:t></m:r></m:e><m:sub><m:r><m:t>1</m:t></m:r></m:sub></m:sSub><m:r><m:rPr><m:sty m:val="p" /></m:rPr><m:t>−</m:t></m:r><m:sSub><m:e><m:r><m:t>μ</m:t></m:r></m:e><m:sub><m:r><m:t>2</m:t></m:r></m:sub></m:sSub><m:r><m:rPr><m:sty m:val="p" /></m:rPr><m:t>≠</m:t></m:r><m:r><m:t>0</m:t></m:r><m:r><m:rPr><m:sty m:val="p" /></m:rPr><m:t>,</m:t></m:r><m:r><m:t> </m:t></m:r><m:r><m:rPr><m:sty m:val="p" /></m:rPr><m:t>&gt;</m:t></m:r><m:r><m:t>0</m:t></m:r><m:r><m:rPr><m:sty m:val="p" /></m:rPr><m:t>,</m:t></m:r><m:r><m:t> </m:t></m:r><m:r><m:rPr><m:sty m:val="p" /></m:rPr><m:t>&lt;</m:t></m:r><m:r><m:t>0</m:t></m:r></m:oMath></a14:m></a:p></a:txBody></a:tc><a:tc><a:txBody><a:bodyPr /><a:lstStyle /><a:p><a:pPr lvl="0" indent="0" marL="0" algn="l"><a:buNone /></a:pPr><a:r><a:rPr /><a:t>Is average income higher in eastern than western states?</a:t></a:r></a:p></a:txBody></a:tc></a:tr></a:tbl></a:graphicData></a:graphic></p:graphicFrame></p:spTree></p:cSld></p:sld>
 </file>
 
 <file path=ppt/slides/slide8.xml><?xml version="1.0" encoding="utf-8"?>

</xml_diff>

<commit_message>
Randomization v2: density levels + slide fixes
- New 'coursepack-sparse' level (= the lean worksheet profile Jeff liked:
  objectives + hypothesis-forms table + examples, exposition stripped);
  retire the redundant standalone worksheet.
- Add '.elaboration' depth role: textbook/solutions keep 'going deeper'
  asides; all in-class packs drop them. One demo aside added.
- Slides: fix math (KaTeX + self-contained embed), use the BOOK example
  numbers as slide headers (no synthetic 'Example 1/2/3'), declare a real
  pptx format (fixes the unopenable PowerPoint), and add a slides PDF
  rendered from the deck via LibreOffice.
- Share page reworked into a density spectrum (book -> slides).

Co-Authored-By: Claude Opus 4.8 <noreply@anthropic.com>
Claude-Session: https://claude.ai/code/session_01ApPPVtS7Gk1xQdKrjLJbBy
</commit_message>
<xml_diff>
--- a/STAT145/resources-2027/randomization/slides.pptx
+++ b/STAT145/resources-2027/randomization/slides.pptx
@@ -3230,7 +3230,7 @@
             </a:pPr>
             <a:r>
               <a:rPr/>
-              <a:t>Example 3</a:t>
+              <a:t>Class Example 7.2: Opportunity cost</a:t>
             </a:r>
           </a:p>
         </p:txBody>
@@ -3251,15 +3251,6 @@
             <p:txBody>
               <a:bodyPr/>
               <a:lstStyle/>
-              <a:p>
-                <a:pPr lvl="0" indent="0" marL="0">
-                  <a:buNone/>
-                </a:pPr>
-                <a:r>
-                  <a:rPr b="1"/>
-                  <a:t>Class Example 7.2: Opportunity cost</a:t>
-                </a:r>
-              </a:p>
               <a:p>
                 <a:pPr lvl="0" indent="0" marL="0">
                   <a:buNone/>
@@ -3858,7 +3849,7 @@
             </a:pPr>
             <a:r>
               <a:rPr/>
-              <a:t>Example 4</a:t>
+              <a:t>Class Example 7.3: Opportunity cost, revisited</a:t>
             </a:r>
           </a:p>
         </p:txBody>
@@ -3879,15 +3870,6 @@
             <p:txBody>
               <a:bodyPr/>
               <a:lstStyle/>
-              <a:p>
-                <a:pPr lvl="0" indent="0" marL="0">
-                  <a:buNone/>
-                </a:pPr>
-                <a:r>
-                  <a:rPr b="1"/>
-                  <a:t>Class Example 7.3: Opportunity cost, revisited</a:t>
-                </a:r>
-              </a:p>
               <a:p>
                 <a:pPr lvl="0" indent="0" marL="0">
                   <a:buNone/>
@@ -4246,7 +4228,7 @@
             </a:pPr>
             <a:r>
               <a:rPr/>
-              <a:t>Example 5</a:t>
+              <a:t>Activity</a:t>
             </a:r>
           </a:p>
         </p:txBody>
@@ -4533,36 +4515,51 @@
           <a:chExt cx="0" cy="0"/>
         </a:xfrm>
       </p:grpSpPr>
-      <p:sp>
-        <p:nvSpPr>
-          <p:cNvPr id="2" name="Title 1"/>
-          <p:cNvSpPr>
-            <a:spLocks noGrp="1"/>
-          </p:cNvSpPr>
-          <p:nvPr>
-            <p:ph type="title"/>
-          </p:nvPr>
-        </p:nvSpPr>
-        <p:spPr>
-          <a:xfrm>
-            <a:off x="457201" y="204787"/>
-            <a:ext cx="3008313" cy="871538"/>
-          </a:xfrm>
-        </p:spPr>
-        <p:txBody>
-          <a:bodyPr/>
-          <a:lstStyle/>
-          <a:p>
-            <a:pPr lvl="0" indent="0" marL="0">
-              <a:buNone/>
-            </a:pPr>
-            <a:r>
-              <a:rPr/>
-              <a:t>Example 6</a:t>
-            </a:r>
-          </a:p>
-        </p:txBody>
-      </p:sp>
+      <mc:AlternateContent xmlns:mc="http://schemas.openxmlformats.org/markup-compatibility/2006">
+        <mc:Choice xmlns:a14="http://schemas.microsoft.com/office/drawing/2010/main" Requires="a14">
+          <p:sp>
+            <p:nvSpPr>
+              <p:cNvPr id="2" name="Title 1"/>
+              <p:cNvSpPr>
+                <a:spLocks noGrp="1"/>
+              </p:cNvSpPr>
+              <p:nvPr>
+                <p:ph type="title"/>
+              </p:nvPr>
+            </p:nvSpPr>
+            <p:spPr>
+              <a:xfrm>
+                <a:off x="457201" y="204787"/>
+                <a:ext cx="3008313" cy="871538"/>
+              </a:xfrm>
+            </p:spPr>
+            <p:txBody>
+              <a:bodyPr/>
+              <a:lstStyle/>
+              <a:p>
+                <a:pPr lvl="0" indent="0" marL="0">
+                  <a:buNone/>
+                </a:pPr>
+                <a:r>
+                  <a:rPr/>
+                  <a:t>Class Example 7.4: Estimating a </a:t>
+                </a:r>
+                <a14:m>
+                  <m:oMath xmlns:m="http://schemas.openxmlformats.org/officeDocument/2006/math">
+                    <m:r>
+                      <m:t>p</m:t>
+                    </m:r>
+                  </m:oMath>
+                </a14:m>
+                <a:r>
+                  <a:rPr/>
+                  <a:t>-value from a randomization distribution</a:t>
+                </a:r>
+              </a:p>
+            </p:txBody>
+          </p:sp>
+        </mc:Choice>
+      </mc:AlternateContent>
       <mc:AlternateContent xmlns:mc="http://schemas.openxmlformats.org/markup-compatibility/2006">
         <mc:Choice xmlns:a14="http://schemas.microsoft.com/office/drawing/2010/main" Requires="a14">
           <p:sp>
@@ -4579,26 +4576,6 @@
             <p:txBody>
               <a:bodyPr/>
               <a:lstStyle/>
-              <a:p>
-                <a:pPr lvl="0" indent="0" marL="0">
-                  <a:buNone/>
-                </a:pPr>
-                <a:r>
-                  <a:rPr b="1"/>
-                  <a:t>Class Example 7.4: Estimating a </a:t>
-                </a:r>
-                <a14:m>
-                  <m:oMath xmlns:m="http://schemas.openxmlformats.org/officeDocument/2006/math">
-                    <m:r>
-                      <m:t>p</m:t>
-                    </m:r>
-                  </m:oMath>
-                </a14:m>
-                <a:r>
-                  <a:rPr b="1"/>
-                  <a:t>-value from a randomization distribution</a:t>
-                </a:r>
-              </a:p>
               <a:p>
                 <a:pPr lvl="0" indent="0" marL="0">
                   <a:buNone/>
@@ -5351,36 +5328,51 @@
           <a:chExt cx="0" cy="0"/>
         </a:xfrm>
       </p:grpSpPr>
-      <p:sp>
-        <p:nvSpPr>
-          <p:cNvPr id="2" name="Title 1"/>
-          <p:cNvSpPr>
-            <a:spLocks noGrp="1"/>
-          </p:cNvSpPr>
-          <p:nvPr>
-            <p:ph type="title"/>
-          </p:nvPr>
-        </p:nvSpPr>
-        <p:spPr>
-          <a:xfrm>
-            <a:off x="457201" y="204787"/>
-            <a:ext cx="3008313" cy="871538"/>
-          </a:xfrm>
-        </p:spPr>
-        <p:txBody>
-          <a:bodyPr/>
-          <a:lstStyle/>
-          <a:p>
-            <a:pPr lvl="0" indent="0" marL="0">
-              <a:buNone/>
-            </a:pPr>
-            <a:r>
-              <a:rPr/>
-              <a:t>Example 7</a:t>
-            </a:r>
-          </a:p>
-        </p:txBody>
-      </p:sp>
+      <mc:AlternateContent xmlns:mc="http://schemas.openxmlformats.org/markup-compatibility/2006">
+        <mc:Choice xmlns:a14="http://schemas.microsoft.com/office/drawing/2010/main" Requires="a14">
+          <p:sp>
+            <p:nvSpPr>
+              <p:cNvPr id="2" name="Title 1"/>
+              <p:cNvSpPr>
+                <a:spLocks noGrp="1"/>
+              </p:cNvSpPr>
+              <p:nvPr>
+                <p:ph type="title"/>
+              </p:nvPr>
+            </p:nvSpPr>
+            <p:spPr>
+              <a:xfrm>
+                <a:off x="457201" y="204787"/>
+                <a:ext cx="3008313" cy="871538"/>
+              </a:xfrm>
+            </p:spPr>
+            <p:txBody>
+              <a:bodyPr/>
+              <a:lstStyle/>
+              <a:p>
+                <a:pPr lvl="0" indent="0" marL="0">
+                  <a:buNone/>
+                </a:pPr>
+                <a:r>
+                  <a:rPr/>
+                  <a:t>Class Example 7.5: Estimating a </a:t>
+                </a:r>
+                <a14:m>
+                  <m:oMath xmlns:m="http://schemas.openxmlformats.org/officeDocument/2006/math">
+                    <m:r>
+                      <m:t>p</m:t>
+                    </m:r>
+                  </m:oMath>
+                </a14:m>
+                <a:r>
+                  <a:rPr/>
+                  <a:t>-value from a randomization distribution…continued</a:t>
+                </a:r>
+              </a:p>
+            </p:txBody>
+          </p:sp>
+        </mc:Choice>
+      </mc:AlternateContent>
       <mc:AlternateContent xmlns:mc="http://schemas.openxmlformats.org/markup-compatibility/2006">
         <mc:Choice xmlns:a14="http://schemas.microsoft.com/office/drawing/2010/main" Requires="a14">
           <p:sp>
@@ -5397,26 +5389,6 @@
             <p:txBody>
               <a:bodyPr/>
               <a:lstStyle/>
-              <a:p>
-                <a:pPr lvl="0" indent="0" marL="0">
-                  <a:buNone/>
-                </a:pPr>
-                <a:r>
-                  <a:rPr b="1"/>
-                  <a:t>Class Example 7.5: Estimating a </a:t>
-                </a:r>
-                <a14:m>
-                  <m:oMath xmlns:m="http://schemas.openxmlformats.org/officeDocument/2006/math">
-                    <m:r>
-                      <m:t>p</m:t>
-                    </m:r>
-                  </m:oMath>
-                </a14:m>
-                <a:r>
-                  <a:rPr b="1"/>
-                  <a:t>-value from a randomization distribution…continued</a:t>
-                </a:r>
-              </a:p>
               <a:p>
                 <a:pPr lvl="0" indent="0" marL="0">
                   <a:buNone/>
@@ -6385,7 +6357,7 @@
             </a:pPr>
             <a:r>
               <a:rPr/>
-              <a:t>Example 8</a:t>
+              <a:t>Class Example 7.6: Migraine Acupuncture Trial</a:t>
             </a:r>
           </a:p>
         </p:txBody>
@@ -6406,15 +6378,6 @@
             <p:txBody>
               <a:bodyPr/>
               <a:lstStyle/>
-              <a:p>
-                <a:pPr lvl="0" indent="0" marL="0">
-                  <a:buNone/>
-                </a:pPr>
-                <a:r>
-                  <a:rPr b="1"/>
-                  <a:t>Class Example 7.6: Migraine Acupuncture Trial</a:t>
-                </a:r>
-              </a:p>
               <a:p>
                 <a:pPr lvl="0" indent="0" marL="0">
                   <a:buNone/>
@@ -7172,7 +7135,7 @@
             </a:pPr>
             <a:r>
               <a:rPr/>
-              <a:t>Example 9</a:t>
+              <a:t>Class Example 7.7: Calorie Counts</a:t>
             </a:r>
           </a:p>
         </p:txBody>
@@ -7193,15 +7156,6 @@
             <p:txBody>
               <a:bodyPr/>
               <a:lstStyle/>
-              <a:p>
-                <a:pPr lvl="0" indent="0" marL="0">
-                  <a:buNone/>
-                </a:pPr>
-                <a:r>
-                  <a:rPr b="1"/>
-                  <a:t>Class Example 7.7: Calorie Counts</a:t>
-                </a:r>
-              </a:p>
               <a:p>
                 <a:pPr lvl="0" indent="0" marL="0">
                   <a:buNone/>
@@ -7679,7 +7633,7 @@
             </a:pPr>
             <a:r>
               <a:rPr/>
-              <a:t>Example 10</a:t>
+              <a:t>Class Example 7.8: Cereal study revisited</a:t>
             </a:r>
           </a:p>
         </p:txBody>
@@ -7700,15 +7654,6 @@
             <p:txBody>
               <a:bodyPr/>
               <a:lstStyle/>
-              <a:p>
-                <a:pPr lvl="0" indent="0" marL="0">
-                  <a:buNone/>
-                </a:pPr>
-                <a:r>
-                  <a:rPr b="1"/>
-                  <a:t>Class Example 7.8: Cereal study revisited</a:t>
-                </a:r>
-              </a:p>
               <a:p>
                 <a:pPr lvl="0" indent="0" marL="0">
                   <a:buNone/>
@@ -8093,7 +8038,7 @@
             </a:pPr>
             <a:r>
               <a:rPr/>
-              <a:t>Example 11</a:t>
+              <a:t>Class Example 7.9: Red wine and weight loss</a:t>
             </a:r>
           </a:p>
         </p:txBody>
@@ -8114,15 +8059,6 @@
             <p:txBody>
               <a:bodyPr/>
               <a:lstStyle/>
-              <a:p>
-                <a:pPr lvl="0" indent="0" marL="0">
-                  <a:buNone/>
-                </a:pPr>
-                <a:r>
-                  <a:rPr b="1"/>
-                  <a:t>Class Example 7.9: Red wine and weight loss</a:t>
-                </a:r>
-              </a:p>
               <a:p>
                 <a:pPr lvl="0" indent="0" marL="0">
                   <a:buNone/>
@@ -8517,7 +8453,7 @@
             </a:pPr>
             <a:r>
               <a:rPr/>
-              <a:t>Example 12</a:t>
+              <a:t>Class Example 7.10: Red wine and weight loss revisted</a:t>
             </a:r>
           </a:p>
         </p:txBody>
@@ -8538,15 +8474,6 @@
             <p:txBody>
               <a:bodyPr/>
               <a:lstStyle/>
-              <a:p>
-                <a:pPr lvl="0" indent="0" marL="0">
-                  <a:buNone/>
-                </a:pPr>
-                <a:r>
-                  <a:rPr b="1"/>
-                  <a:t>Class Example 7.10: Red wine and weight loss revisted</a:t>
-                </a:r>
-              </a:p>
               <a:p>
                 <a:pPr lvl="0" indent="0" marL="0">
                   <a:buNone/>
@@ -8800,7 +8727,7 @@
             </a:pPr>
             <a:r>
               <a:rPr/>
-              <a:t>Example 13</a:t>
+              <a:t>Class Example 7.11: Migraine Acupuncture Trial revisited</a:t>
             </a:r>
           </a:p>
         </p:txBody>
@@ -8821,15 +8748,6 @@
             <p:txBody>
               <a:bodyPr/>
               <a:lstStyle/>
-              <a:p>
-                <a:pPr lvl="0" indent="0" marL="0">
-                  <a:buNone/>
-                </a:pPr>
-                <a:r>
-                  <a:rPr b="1"/>
-                  <a:t>Class Example 7.11: Migraine Acupuncture Trial revisited</a:t>
-                </a:r>
-              </a:p>
               <a:p>
                 <a:pPr lvl="0" indent="0" marL="0">
                   <a:buNone/>
@@ -9000,7 +8918,7 @@
             </a:pPr>
             <a:r>
               <a:rPr/>
-              <a:t>Example 14</a:t>
+              <a:t>Class Example 7.12: Calorie count revisited</a:t>
             </a:r>
           </a:p>
         </p:txBody>
@@ -9021,15 +8939,6 @@
             <p:txBody>
               <a:bodyPr/>
               <a:lstStyle/>
-              <a:p>
-                <a:pPr lvl="0" indent="0" marL="0">
-                  <a:buNone/>
-                </a:pPr>
-                <a:r>
-                  <a:rPr b="1"/>
-                  <a:t>Class Example 7.12: Calorie count revisited</a:t>
-                </a:r>
-              </a:p>
               <a:p>
                 <a:pPr lvl="0" indent="0" marL="0">
                   <a:buNone/>
@@ -9200,7 +9109,7 @@
             </a:pPr>
             <a:r>
               <a:rPr/>
-              <a:t>Example 15</a:t>
+              <a:t>Class Example 7.13: Cereal study revisited</a:t>
             </a:r>
           </a:p>
         </p:txBody>
@@ -9221,15 +9130,6 @@
             <p:txBody>
               <a:bodyPr/>
               <a:lstStyle/>
-              <a:p>
-                <a:pPr lvl="0" indent="0" marL="0">
-                  <a:buNone/>
-                </a:pPr>
-                <a:r>
-                  <a:rPr b="1"/>
-                  <a:t>Class Example 7.13: Cereal study revisited</a:t>
-                </a:r>
-              </a:p>
               <a:p>
                 <a:pPr lvl="0" indent="0" marL="0">
                   <a:buNone/>
@@ -9386,7 +9286,7 @@
             </a:pPr>
             <a:r>
               <a:rPr/>
-              <a:t>Example 16</a:t>
+              <a:t>Class Example 7.14: Red wine and weight loss revisted</a:t>
             </a:r>
           </a:p>
         </p:txBody>
@@ -9407,15 +9307,6 @@
             <p:txBody>
               <a:bodyPr/>
               <a:lstStyle/>
-              <a:p>
-                <a:pPr lvl="0" indent="0" marL="0">
-                  <a:buNone/>
-                </a:pPr>
-                <a:r>
-                  <a:rPr b="1"/>
-                  <a:t>Class Example 7.14: Red wine and weight loss revisted</a:t>
-                </a:r>
-              </a:p>
               <a:p>
                 <a:pPr lvl="0" indent="0" marL="0">
                   <a:buNone/>
@@ -9984,7 +9875,7 @@
             </a:pPr>
             <a:r>
               <a:rPr/>
-              <a:t>Example 17</a:t>
+              <a:t>Class Example 4.15: Errors in a drug study</a:t>
             </a:r>
           </a:p>
         </p:txBody>
@@ -10005,15 +9896,6 @@
             <p:txBody>
               <a:bodyPr/>
               <a:lstStyle/>
-              <a:p>
-                <a:pPr lvl="0" indent="0" marL="0">
-                  <a:buNone/>
-                </a:pPr>
-                <a:r>
-                  <a:rPr b="1"/>
-                  <a:t>Class Example 4.15: Errors in a drug study</a:t>
-                </a:r>
-              </a:p>
               <a:p>
                 <a:pPr lvl="0" indent="0" marL="0">
                   <a:buNone/>
@@ -10584,7 +10466,7 @@
             </a:pPr>
             <a:r>
               <a:rPr/>
-              <a:t>Example 1</a:t>
+              <a:t>Activity</a:t>
             </a:r>
           </a:p>
         </p:txBody>
@@ -11286,7 +11168,7 @@
             </a:pPr>
             <a:r>
               <a:rPr/>
-              <a:t>Example 2</a:t>
+              <a:t>Class Example 7.1: Defining statistical hypotheses</a:t>
             </a:r>
           </a:p>
         </p:txBody>
@@ -11307,15 +11189,6 @@
             <p:txBody>
               <a:bodyPr/>
               <a:lstStyle/>
-              <a:p>
-                <a:pPr lvl="0" indent="0" marL="0">
-                  <a:buNone/>
-                </a:pPr>
-                <a:r>
-                  <a:rPr b="1"/>
-                  <a:t>Class Example 7.1: Defining statistical hypotheses</a:t>
-                </a:r>
-              </a:p>
               <a:p>
                 <a:pPr lvl="0" indent="0" marL="0">
                   <a:buNone/>

</xml_diff>

<commit_message>
Randomization v2: self-contained Opportunity Cost summary in Example 7.2
The study was described only in exposition above the example, which the
sparse pack and slides cull -- so in those lean targets Example 7.2
referenced a study with no setup. Move a concise summary (150 students,
$14.99 video, control vs reworded treatment, success = not buy) inside
the example box so it travels to every target.

Co-Authored-By: Claude Opus 4.8 <noreply@anthropic.com>
Claude-Session: https://claude.ai/code/session_01ApPPVtS7Gk1xQdKrjLJbBy
</commit_message>
<xml_diff>
--- a/STAT145/resources-2027/randomization/slides.pptx
+++ b/STAT145/resources-2027/randomization/slides.pptx
@@ -3257,7 +3257,47 @@
                 </a:pPr>
                 <a:r>
                   <a:rPr/>
-                  <a:t>Using the opportunity cost case study, answer the following questions:</a:t>
+                  <a:t>In the </a:t>
+                </a:r>
+                <a:r>
+                  <a:rPr i="1"/>
+                  <a:t>opportunity cost</a:t>
+                </a:r>
+                <a:r>
+                  <a:rPr/>
+                  <a:t> study, 150 college students each decided whether to buy a $14.99 video. The 75 students in the </a:t>
+                </a:r>
+                <a:r>
+                  <a:rPr b="1"/>
+                  <a:t>control</a:t>
+                </a:r>
+                <a:r>
+                  <a:rPr/>
+                  <a:t> group chose between “buy” and “not buy,” while the 75 in the </a:t>
+                </a:r>
+                <a:r>
+                  <a:rPr b="1"/>
+                  <a:t>treatment</a:t>
+                </a:r>
+                <a:r>
+                  <a:rPr/>
+                  <a:t> group saw a reworded reminder — “not buy, </a:t>
+                </a:r>
+                <a:r>
+                  <a:rPr i="1"/>
+                  <a:t>and keep the $14.99 for other purchases</a:t>
+                </a:r>
+                <a:r>
+                  <a:rPr/>
+                  <a:t>.” A “success” is a student who chooses </a:t>
+                </a:r>
+                <a:r>
+                  <a:rPr i="1"/>
+                  <a:t>not</a:t>
+                </a:r>
+                <a:r>
+                  <a:rPr/>
+                  <a:t> to buy the video. Using this study, answer the following questions:</a:t>
                 </a:r>
               </a:p>
               <a:p>

</xml_diff>